<commit_message>
Sensitivity Output with uncertainity
</commit_message>
<xml_diff>
--- a/Sens_output_MK.pptx
+++ b/Sens_output_MK.pptx
@@ -9,6 +9,8 @@
     <p:sldId id="259" r:id="rId3"/>
     <p:sldId id="260" r:id="rId4"/>
     <p:sldId id="261" r:id="rId5"/>
+    <p:sldId id="262" r:id="rId6"/>
+    <p:sldId id="263" r:id="rId7"/>
   </p:sldIdLst>
   <p:sldSz cx="12192000" cy="6858000"/>
   <p:notesSz cx="6858000" cy="9144000"/>
@@ -107,6 +109,11 @@
       </a:defRPr>
     </a:lvl9pPr>
   </p:defaultTextStyle>
+  <p:extLst>
+    <p:ext uri="{EFAFB233-063F-42B5-8137-9DF3F51BA10A}">
+      <p15:sldGuideLst xmlns:p15="http://schemas.microsoft.com/office/powerpoint/2012/main"/>
+    </p:ext>
+  </p:extLst>
 </p:presentation>
 </file>
 
@@ -259,7 +266,7 @@
           <a:p>
             <a:fld id="{E4693F64-EFAE-48FB-A6C7-8A382A45C195}" type="datetimeFigureOut">
               <a:rPr lang="en-GB" smtClean="0"/>
-              <a:t>18/08/2026</a:t>
+              <a:t>31/08/2026</a:t>
             </a:fld>
             <a:endParaRPr lang="en-GB"/>
           </a:p>
@@ -459,7 +466,7 @@
           <a:p>
             <a:fld id="{E4693F64-EFAE-48FB-A6C7-8A382A45C195}" type="datetimeFigureOut">
               <a:rPr lang="en-GB" smtClean="0"/>
-              <a:t>18/08/2026</a:t>
+              <a:t>31/08/2026</a:t>
             </a:fld>
             <a:endParaRPr lang="en-GB"/>
           </a:p>
@@ -669,7 +676,7 @@
           <a:p>
             <a:fld id="{E4693F64-EFAE-48FB-A6C7-8A382A45C195}" type="datetimeFigureOut">
               <a:rPr lang="en-GB" smtClean="0"/>
-              <a:t>18/08/2026</a:t>
+              <a:t>31/08/2026</a:t>
             </a:fld>
             <a:endParaRPr lang="en-GB"/>
           </a:p>
@@ -869,7 +876,7 @@
           <a:p>
             <a:fld id="{E4693F64-EFAE-48FB-A6C7-8A382A45C195}" type="datetimeFigureOut">
               <a:rPr lang="en-GB" smtClean="0"/>
-              <a:t>18/08/2026</a:t>
+              <a:t>31/08/2026</a:t>
             </a:fld>
             <a:endParaRPr lang="en-GB"/>
           </a:p>
@@ -1145,7 +1152,7 @@
           <a:p>
             <a:fld id="{E4693F64-EFAE-48FB-A6C7-8A382A45C195}" type="datetimeFigureOut">
               <a:rPr lang="en-GB" smtClean="0"/>
-              <a:t>18/08/2026</a:t>
+              <a:t>31/08/2026</a:t>
             </a:fld>
             <a:endParaRPr lang="en-GB"/>
           </a:p>
@@ -1413,7 +1420,7 @@
           <a:p>
             <a:fld id="{E4693F64-EFAE-48FB-A6C7-8A382A45C195}" type="datetimeFigureOut">
               <a:rPr lang="en-GB" smtClean="0"/>
-              <a:t>18/08/2026</a:t>
+              <a:t>31/08/2026</a:t>
             </a:fld>
             <a:endParaRPr lang="en-GB"/>
           </a:p>
@@ -1828,7 +1835,7 @@
           <a:p>
             <a:fld id="{E4693F64-EFAE-48FB-A6C7-8A382A45C195}" type="datetimeFigureOut">
               <a:rPr lang="en-GB" smtClean="0"/>
-              <a:t>18/08/2026</a:t>
+              <a:t>31/08/2026</a:t>
             </a:fld>
             <a:endParaRPr lang="en-GB"/>
           </a:p>
@@ -1970,7 +1977,7 @@
           <a:p>
             <a:fld id="{E4693F64-EFAE-48FB-A6C7-8A382A45C195}" type="datetimeFigureOut">
               <a:rPr lang="en-GB" smtClean="0"/>
-              <a:t>18/08/2026</a:t>
+              <a:t>31/08/2026</a:t>
             </a:fld>
             <a:endParaRPr lang="en-GB"/>
           </a:p>
@@ -2083,7 +2090,7 @@
           <a:p>
             <a:fld id="{E4693F64-EFAE-48FB-A6C7-8A382A45C195}" type="datetimeFigureOut">
               <a:rPr lang="en-GB" smtClean="0"/>
-              <a:t>18/08/2026</a:t>
+              <a:t>31/08/2026</a:t>
             </a:fld>
             <a:endParaRPr lang="en-GB"/>
           </a:p>
@@ -2396,7 +2403,7 @@
           <a:p>
             <a:fld id="{E4693F64-EFAE-48FB-A6C7-8A382A45C195}" type="datetimeFigureOut">
               <a:rPr lang="en-GB" smtClean="0"/>
-              <a:t>18/08/2026</a:t>
+              <a:t>31/08/2026</a:t>
             </a:fld>
             <a:endParaRPr lang="en-GB"/>
           </a:p>
@@ -2685,7 +2692,7 @@
           <a:p>
             <a:fld id="{E4693F64-EFAE-48FB-A6C7-8A382A45C195}" type="datetimeFigureOut">
               <a:rPr lang="en-GB" smtClean="0"/>
-              <a:t>18/08/2026</a:t>
+              <a:t>31/08/2026</a:t>
             </a:fld>
             <a:endParaRPr lang="en-GB"/>
           </a:p>
@@ -2928,7 +2935,7 @@
           <a:p>
             <a:fld id="{E4693F64-EFAE-48FB-A6C7-8A382A45C195}" type="datetimeFigureOut">
               <a:rPr lang="en-GB" smtClean="0"/>
-              <a:t>18/08/2026</a:t>
+              <a:t>31/08/2026</a:t>
             </a:fld>
             <a:endParaRPr lang="en-GB"/>
           </a:p>
@@ -3592,6 +3599,126 @@
     <p:extLst>
       <p:ext uri="{BB962C8B-B14F-4D97-AF65-F5344CB8AC3E}">
         <p14:creationId xmlns:p14="http://schemas.microsoft.com/office/powerpoint/2010/main" val="4120684526"/>
+      </p:ext>
+    </p:extLst>
+  </p:cSld>
+  <p:clrMapOvr>
+    <a:masterClrMapping/>
+  </p:clrMapOvr>
+</p:sld>
+</file>
+
+<file path=ppt/slides/slide5.xml><?xml version="1.0" encoding="utf-8"?>
+<p:sld xmlns:a="http://schemas.openxmlformats.org/drawingml/2006/main" xmlns:r="http://schemas.openxmlformats.org/officeDocument/2006/relationships" xmlns:p="http://schemas.openxmlformats.org/presentationml/2006/main">
+  <p:cSld>
+    <p:spTree>
+      <p:nvGrpSpPr>
+        <p:cNvPr id="1" name=""/>
+        <p:cNvGrpSpPr/>
+        <p:nvPr/>
+      </p:nvGrpSpPr>
+      <p:grpSpPr>
+        <a:xfrm>
+          <a:off x="0" y="0"/>
+          <a:ext cx="0" cy="0"/>
+          <a:chOff x="0" y="0"/>
+          <a:chExt cx="0" cy="0"/>
+        </a:xfrm>
+      </p:grpSpPr>
+      <p:pic>
+        <p:nvPicPr>
+          <p:cNvPr id="3" name="Picture 2">
+            <a:extLst>
+              <a:ext uri="{FF2B5EF4-FFF2-40B4-BE49-F238E27FC236}">
+                <a16:creationId xmlns:a16="http://schemas.microsoft.com/office/drawing/2014/main" id="{2438B170-324A-27A9-0FA1-F5266EA4C7C0}"/>
+              </a:ext>
+            </a:extLst>
+          </p:cNvPr>
+          <p:cNvPicPr>
+            <a:picLocks noChangeAspect="1"/>
+          </p:cNvPicPr>
+          <p:nvPr/>
+        </p:nvPicPr>
+        <p:blipFill>
+          <a:blip r:embed="rId2"/>
+          <a:stretch>
+            <a:fillRect/>
+          </a:stretch>
+        </p:blipFill>
+        <p:spPr>
+          <a:xfrm>
+            <a:off x="262444" y="0"/>
+            <a:ext cx="11667112" cy="6858000"/>
+          </a:xfrm>
+          <a:prstGeom prst="rect">
+            <a:avLst/>
+          </a:prstGeom>
+        </p:spPr>
+      </p:pic>
+    </p:spTree>
+    <p:extLst>
+      <p:ext uri="{BB962C8B-B14F-4D97-AF65-F5344CB8AC3E}">
+        <p14:creationId xmlns:p14="http://schemas.microsoft.com/office/powerpoint/2010/main" val="4265428835"/>
+      </p:ext>
+    </p:extLst>
+  </p:cSld>
+  <p:clrMapOvr>
+    <a:masterClrMapping/>
+  </p:clrMapOvr>
+</p:sld>
+</file>
+
+<file path=ppt/slides/slide6.xml><?xml version="1.0" encoding="utf-8"?>
+<p:sld xmlns:a="http://schemas.openxmlformats.org/drawingml/2006/main" xmlns:r="http://schemas.openxmlformats.org/officeDocument/2006/relationships" xmlns:p="http://schemas.openxmlformats.org/presentationml/2006/main">
+  <p:cSld>
+    <p:spTree>
+      <p:nvGrpSpPr>
+        <p:cNvPr id="1" name=""/>
+        <p:cNvGrpSpPr/>
+        <p:nvPr/>
+      </p:nvGrpSpPr>
+      <p:grpSpPr>
+        <a:xfrm>
+          <a:off x="0" y="0"/>
+          <a:ext cx="0" cy="0"/>
+          <a:chOff x="0" y="0"/>
+          <a:chExt cx="0" cy="0"/>
+        </a:xfrm>
+      </p:grpSpPr>
+      <p:pic>
+        <p:nvPicPr>
+          <p:cNvPr id="5" name="Picture 4">
+            <a:extLst>
+              <a:ext uri="{FF2B5EF4-FFF2-40B4-BE49-F238E27FC236}">
+                <a16:creationId xmlns:a16="http://schemas.microsoft.com/office/drawing/2014/main" id="{42B15454-87B5-B6AB-B315-62EC8072781F}"/>
+              </a:ext>
+            </a:extLst>
+          </p:cNvPr>
+          <p:cNvPicPr>
+            <a:picLocks noChangeAspect="1"/>
+          </p:cNvPicPr>
+          <p:nvPr/>
+        </p:nvPicPr>
+        <p:blipFill>
+          <a:blip r:embed="rId2"/>
+          <a:stretch>
+            <a:fillRect/>
+          </a:stretch>
+        </p:blipFill>
+        <p:spPr>
+          <a:xfrm>
+            <a:off x="262444" y="0"/>
+            <a:ext cx="11667112" cy="6858000"/>
+          </a:xfrm>
+          <a:prstGeom prst="rect">
+            <a:avLst/>
+          </a:prstGeom>
+        </p:spPr>
+      </p:pic>
+    </p:spTree>
+    <p:extLst>
+      <p:ext uri="{BB962C8B-B14F-4D97-AF65-F5344CB8AC3E}">
+        <p14:creationId xmlns:p14="http://schemas.microsoft.com/office/powerpoint/2010/main" val="513145071"/>
       </p:ext>
     </p:extLst>
   </p:cSld>

</xml_diff>